<commit_message>
Presentation: show both at-risk and loyal demo examples on the live-demo slide
</commit_message>
<xml_diff>
--- a/presentation/Churn_Prediction_Final_Presentation.pptx
+++ b/presentation/Churn_Prediction_Final_Presentation.pptx
@@ -600,7 +600,7 @@
           <a:p>
             <a:r>
               <a:rPr lang="en-US" dirty="0"/>
-              <a:t>Now the live demo. This is the actual trained model served by a small Flask app. I load an at-risk customer, the model returns 94.9% churn, high risk, the suggested action, and the SHAP drivers behind it. Then I'll load a loyal customer to show a low-risk case.</a:t>
+              <a:t>Now the live demo — the actual trained model served by a small Flask app. On the left, an at-risk customer: 94.9% churn, high risk, with the action and the SHAP drivers. On the right, a loyal customer: 1.1%, low risk, drivers pushing toward staying. I'll reproduce both live in the app.</a:t>
             </a:r>
             <a:endParaRPr lang="en-US" dirty="0"/>
           </a:p>
@@ -2369,18 +2369,71 @@
       </p:sp>
       <p:sp>
         <p:nvSpPr>
-          <p:cNvPr id="4" name="Shape 2"/>
-          <p:cNvSpPr/>
-          <p:nvPr/>
-        </p:nvSpPr>
-        <p:spPr>
-          <a:xfrm>
-            <a:off x="548640" y="1874520"/>
-            <a:ext cx="7040880" cy="4297680"/>
+          <p:cNvPr id="4" name="Text 2"/>
+          <p:cNvSpPr/>
+          <p:nvPr/>
+        </p:nvSpPr>
+        <p:spPr>
+          <a:xfrm>
+            <a:off x="548640" y="1691640"/>
+            <a:ext cx="5440680" cy="365760"/>
+          </a:xfrm>
+          <a:prstGeom prst="rect">
+            <a:avLst/>
+          </a:prstGeom>
+          <a:noFill/>
+          <a:ln/>
+        </p:spPr>
+        <p:txBody>
+          <a:bodyPr wrap="square" lIns="0" tIns="0" rIns="0" bIns="0" rtlCol="0" anchor="ctr"/>
+          <a:lstStyle/>
+          <a:p>
+            <a:pPr indent="0" marL="0">
+              <a:buNone/>
+            </a:pPr>
+            <a:r>
+              <a:rPr lang="en-US" sz="1500" b="1" dirty="0">
+                <a:solidFill>
+                  <a:srgbClr val="FFFFFF"/>
+                </a:solidFill>
+                <a:latin typeface="Calibri" pitchFamily="34" charset="0"/>
+                <a:ea typeface="Calibri" pitchFamily="34" charset="-122"/>
+                <a:cs typeface="Calibri" pitchFamily="34" charset="-120"/>
+              </a:rPr>
+              <a:t>At-risk customer  </a:t>
+            </a:r>
+            <a:pPr indent="0" marL="0">
+              <a:buNone/>
+            </a:pPr>
+            <a:r>
+              <a:rPr lang="en-US" sz="1500" b="1" dirty="0">
+                <a:solidFill>
+                  <a:srgbClr val="EF4767"/>
+                </a:solidFill>
+                <a:latin typeface="Calibri" pitchFamily="34" charset="0"/>
+                <a:ea typeface="Calibri" pitchFamily="34" charset="-122"/>
+                <a:cs typeface="Calibri" pitchFamily="34" charset="-120"/>
+              </a:rPr>
+              <a:t>→ 94.9% · HIGH RISK</a:t>
+            </a:r>
+            <a:endParaRPr lang="en-US" sz="1500" dirty="0"/>
+          </a:p>
+        </p:txBody>
+      </p:sp>
+      <p:sp>
+        <p:nvSpPr>
+          <p:cNvPr id="5" name="Shape 3"/>
+          <p:cNvSpPr/>
+          <p:nvPr/>
+        </p:nvSpPr>
+        <p:spPr>
+          <a:xfrm>
+            <a:off x="548640" y="2148840"/>
+            <a:ext cx="5440680" cy="2971800"/>
           </a:xfrm>
           <a:prstGeom prst="roundRect">
             <a:avLst>
-              <a:gd name="adj" fmla="val 2553"/>
+              <a:gd name="adj" fmla="val 3692"/>
             </a:avLst>
           </a:prstGeom>
           <a:solidFill>
@@ -2396,7 +2449,7 @@
       </p:sp>
       <p:pic>
         <p:nvPicPr>
-          <p:cNvPr id="5" name="Image 0" descr="presentation/assets/demo_high.png">    </p:cNvPr>
+          <p:cNvPr id="6" name="Image 0" descr="presentation/assets/demo_high_crop.png">    </p:cNvPr>
           <p:cNvPicPr>
             <a:picLocks noChangeAspect="1"/>
           </p:cNvPicPr>
@@ -2410,8 +2463,8 @@
         </p:blipFill>
         <p:spPr>
           <a:xfrm>
-            <a:off x="1188720" y="1965960"/>
-            <a:ext cx="5760720" cy="4114800"/>
+            <a:off x="1342339" y="2258568"/>
+            <a:ext cx="3853282" cy="2752344"/>
           </a:xfrm>
           <a:prstGeom prst="rect">
             <a:avLst/>
@@ -2420,77 +2473,14 @@
       </p:pic>
       <p:sp>
         <p:nvSpPr>
-          <p:cNvPr id="6" name="Shape 3"/>
-          <p:cNvSpPr/>
-          <p:nvPr/>
-        </p:nvSpPr>
-        <p:spPr>
-          <a:xfrm>
-            <a:off x="7772400" y="1965960"/>
-            <a:ext cx="457200" cy="457200"/>
-          </a:xfrm>
-          <a:prstGeom prst="roundRect">
-            <a:avLst>
-              <a:gd name="adj" fmla="val 50000"/>
-            </a:avLst>
-          </a:prstGeom>
-          <a:solidFill>
-            <a:srgbClr val="EF4767">
-              <a:alpha val="25000"/>
-            </a:srgbClr>
-          </a:solidFill>
-          <a:ln/>
-        </p:spPr>
-      </p:sp>
-      <p:sp>
-        <p:nvSpPr>
           <p:cNvPr id="7" name="Text 4"/>
           <p:cNvSpPr/>
           <p:nvPr/>
         </p:nvSpPr>
         <p:spPr>
           <a:xfrm>
-            <a:off x="7772400" y="1965960"/>
-            <a:ext cx="457200" cy="457200"/>
-          </a:xfrm>
-          <a:prstGeom prst="rect">
-            <a:avLst/>
-          </a:prstGeom>
-          <a:noFill/>
-          <a:ln/>
-        </p:spPr>
-        <p:txBody>
-          <a:bodyPr wrap="square" lIns="0" tIns="0" rIns="0" bIns="0" rtlCol="0" anchor="ctr"/>
-          <a:lstStyle/>
-          <a:p>
-            <a:pPr algn="ctr" indent="0" marL="0">
-              <a:buNone/>
-            </a:pPr>
-            <a:r>
-              <a:rPr lang="en-US" sz="1800" b="1" dirty="0">
-                <a:solidFill>
-                  <a:srgbClr val="EF4767"/>
-                </a:solidFill>
-                <a:latin typeface="Bookman Old Style" pitchFamily="34" charset="0"/>
-                <a:ea typeface="Bookman Old Style" pitchFamily="34" charset="-122"/>
-                <a:cs typeface="Bookman Old Style" pitchFamily="34" charset="-120"/>
-              </a:rPr>
-              <a:t>1</a:t>
-            </a:r>
-            <a:endParaRPr lang="en-US" sz="1800" dirty="0"/>
-          </a:p>
-        </p:txBody>
-      </p:sp>
-      <p:sp>
-        <p:nvSpPr>
-          <p:cNvPr id="8" name="Text 5"/>
-          <p:cNvSpPr/>
-          <p:nvPr/>
-        </p:nvSpPr>
-        <p:spPr>
-          <a:xfrm>
-            <a:off x="8412480" y="1920240"/>
-            <a:ext cx="3227832" cy="365760"/>
+            <a:off x="6199632" y="1691640"/>
+            <a:ext cx="5440680" cy="365760"/>
           </a:xfrm>
           <a:prstGeom prst="rect">
             <a:avLst/>
@@ -2506,351 +2496,95 @@
               <a:buNone/>
             </a:pPr>
             <a:r>
-              <a:rPr lang="en-US" sz="1600" b="1" dirty="0">
+              <a:rPr lang="en-US" sz="1500" b="1" dirty="0">
                 <a:solidFill>
                   <a:srgbClr val="FFFFFF"/>
-                </a:solidFill>
-                <a:latin typeface="Bookman Old Style" pitchFamily="34" charset="0"/>
-                <a:ea typeface="Bookman Old Style" pitchFamily="34" charset="-122"/>
-                <a:cs typeface="Bookman Old Style" pitchFamily="34" charset="-120"/>
-              </a:rPr>
-              <a:t>Enter a customer</a:t>
-            </a:r>
-            <a:endParaRPr lang="en-US" sz="1600" dirty="0"/>
-          </a:p>
-        </p:txBody>
-      </p:sp>
-      <p:sp>
-        <p:nvSpPr>
-          <p:cNvPr id="9" name="Text 6"/>
-          <p:cNvSpPr/>
-          <p:nvPr/>
-        </p:nvSpPr>
-        <p:spPr>
-          <a:xfrm>
-            <a:off x="8412480" y="2267712"/>
-            <a:ext cx="3227832" cy="640080"/>
-          </a:xfrm>
-          <a:prstGeom prst="rect">
-            <a:avLst/>
-          </a:prstGeom>
-          <a:noFill/>
-          <a:ln/>
-        </p:spPr>
-        <p:txBody>
-          <a:bodyPr wrap="square" lIns="0" tIns="0" rIns="0" bIns="0" rtlCol="0" anchor="ctr"/>
-          <a:lstStyle/>
-          <a:p>
-            <a:pPr indent="0" marL="0">
-              <a:buNone/>
-            </a:pPr>
-            <a:r>
-              <a:rPr lang="en-US" sz="1250" dirty="0">
-                <a:solidFill>
-                  <a:srgbClr val="9AA0BD"/>
                 </a:solidFill>
                 <a:latin typeface="Calibri" pitchFamily="34" charset="0"/>
                 <a:ea typeface="Calibri" pitchFamily="34" charset="-122"/>
                 <a:cs typeface="Calibri" pitchFamily="34" charset="-120"/>
               </a:rPr>
-              <a:t>Profile, subscription and 30-day engagement.</a:t>
-            </a:r>
-            <a:endParaRPr lang="en-US" sz="1250" dirty="0"/>
-          </a:p>
-        </p:txBody>
-      </p:sp>
-      <p:sp>
-        <p:nvSpPr>
-          <p:cNvPr id="10" name="Shape 7"/>
-          <p:cNvSpPr/>
-          <p:nvPr/>
-        </p:nvSpPr>
-        <p:spPr>
-          <a:xfrm>
-            <a:off x="7772400" y="3017520"/>
-            <a:ext cx="457200" cy="457200"/>
-          </a:xfrm>
-          <a:prstGeom prst="roundRect">
-            <a:avLst>
-              <a:gd name="adj" fmla="val 50000"/>
-            </a:avLst>
-          </a:prstGeom>
-          <a:solidFill>
-            <a:srgbClr val="EF4767">
-              <a:alpha val="25000"/>
-            </a:srgbClr>
-          </a:solidFill>
-          <a:ln/>
-        </p:spPr>
-      </p:sp>
-      <p:sp>
-        <p:nvSpPr>
-          <p:cNvPr id="11" name="Text 8"/>
-          <p:cNvSpPr/>
-          <p:nvPr/>
-        </p:nvSpPr>
-        <p:spPr>
-          <a:xfrm>
-            <a:off x="7772400" y="3017520"/>
-            <a:ext cx="457200" cy="457200"/>
-          </a:xfrm>
-          <a:prstGeom prst="rect">
-            <a:avLst/>
-          </a:prstGeom>
-          <a:noFill/>
-          <a:ln/>
-        </p:spPr>
-        <p:txBody>
-          <a:bodyPr wrap="square" lIns="0" tIns="0" rIns="0" bIns="0" rtlCol="0" anchor="ctr"/>
-          <a:lstStyle/>
-          <a:p>
-            <a:pPr algn="ctr" indent="0" marL="0">
-              <a:buNone/>
-            </a:pPr>
-            <a:r>
-              <a:rPr lang="en-US" sz="1800" b="1" dirty="0">
-                <a:solidFill>
-                  <a:srgbClr val="EF4767"/>
-                </a:solidFill>
-                <a:latin typeface="Bookman Old Style" pitchFamily="34" charset="0"/>
-                <a:ea typeface="Bookman Old Style" pitchFamily="34" charset="-122"/>
-                <a:cs typeface="Bookman Old Style" pitchFamily="34" charset="-120"/>
-              </a:rPr>
-              <a:t>2</a:t>
-            </a:r>
-            <a:endParaRPr lang="en-US" sz="1800" dirty="0"/>
-          </a:p>
-        </p:txBody>
-      </p:sp>
-      <p:sp>
-        <p:nvSpPr>
-          <p:cNvPr id="12" name="Text 9"/>
-          <p:cNvSpPr/>
-          <p:nvPr/>
-        </p:nvSpPr>
-        <p:spPr>
-          <a:xfrm>
-            <a:off x="8412480" y="2971800"/>
-            <a:ext cx="3227832" cy="365760"/>
-          </a:xfrm>
-          <a:prstGeom prst="rect">
-            <a:avLst/>
-          </a:prstGeom>
-          <a:noFill/>
-          <a:ln/>
-        </p:spPr>
-        <p:txBody>
-          <a:bodyPr wrap="square" lIns="0" tIns="0" rIns="0" bIns="0" rtlCol="0" anchor="ctr"/>
-          <a:lstStyle/>
-          <a:p>
+              <a:t>Loyal customer  </a:t>
+            </a:r>
             <a:pPr indent="0" marL="0">
               <a:buNone/>
             </a:pPr>
             <a:r>
-              <a:rPr lang="en-US" sz="1600" b="1" dirty="0">
-                <a:solidFill>
-                  <a:srgbClr val="FFFFFF"/>
-                </a:solidFill>
-                <a:latin typeface="Bookman Old Style" pitchFamily="34" charset="0"/>
-                <a:ea typeface="Bookman Old Style" pitchFamily="34" charset="-122"/>
-                <a:cs typeface="Bookman Old Style" pitchFamily="34" charset="-120"/>
-              </a:rPr>
-              <a:t>Model responds</a:t>
-            </a:r>
-            <a:endParaRPr lang="en-US" sz="1600" dirty="0"/>
-          </a:p>
-        </p:txBody>
-      </p:sp>
-      <p:sp>
-        <p:nvSpPr>
-          <p:cNvPr id="13" name="Text 10"/>
-          <p:cNvSpPr/>
-          <p:nvPr/>
-        </p:nvSpPr>
-        <p:spPr>
-          <a:xfrm>
-            <a:off x="8412480" y="3319272"/>
-            <a:ext cx="3227832" cy="640080"/>
-          </a:xfrm>
-          <a:prstGeom prst="rect">
-            <a:avLst/>
-          </a:prstGeom>
-          <a:noFill/>
-          <a:ln/>
-        </p:spPr>
-        <p:txBody>
-          <a:bodyPr wrap="square" lIns="0" tIns="0" rIns="0" bIns="0" rtlCol="0" anchor="ctr"/>
-          <a:lstStyle/>
-          <a:p>
-            <a:pPr indent="0" marL="0">
-              <a:buNone/>
-            </a:pPr>
-            <a:r>
-              <a:rPr lang="en-US" sz="1250" dirty="0">
-                <a:solidFill>
-                  <a:srgbClr val="9AA0BD"/>
+              <a:rPr lang="en-US" sz="1500" b="1" dirty="0">
+                <a:solidFill>
+                  <a:srgbClr val="3ECF8E"/>
                 </a:solidFill>
                 <a:latin typeface="Calibri" pitchFamily="34" charset="0"/>
                 <a:ea typeface="Calibri" pitchFamily="34" charset="-122"/>
                 <a:cs typeface="Calibri" pitchFamily="34" charset="-120"/>
               </a:rPr>
-              <a:t>Churn probability + risk tier + suggested action.</a:t>
-            </a:r>
-            <a:endParaRPr lang="en-US" sz="1250" dirty="0"/>
-          </a:p>
-        </p:txBody>
-      </p:sp>
-      <p:sp>
-        <p:nvSpPr>
-          <p:cNvPr id="14" name="Shape 11"/>
-          <p:cNvSpPr/>
-          <p:nvPr/>
-        </p:nvSpPr>
-        <p:spPr>
-          <a:xfrm>
-            <a:off x="7772400" y="4069080"/>
-            <a:ext cx="457200" cy="457200"/>
+              <a:t>→ 1.1% · LOW RISK</a:t>
+            </a:r>
+            <a:endParaRPr lang="en-US" sz="1500" dirty="0"/>
+          </a:p>
+        </p:txBody>
+      </p:sp>
+      <p:sp>
+        <p:nvSpPr>
+          <p:cNvPr id="8" name="Shape 5"/>
+          <p:cNvSpPr/>
+          <p:nvPr/>
+        </p:nvSpPr>
+        <p:spPr>
+          <a:xfrm>
+            <a:off x="6199632" y="2148840"/>
+            <a:ext cx="5440680" cy="2971800"/>
           </a:xfrm>
           <a:prstGeom prst="roundRect">
             <a:avLst>
-              <a:gd name="adj" fmla="val 50000"/>
+              <a:gd name="adj" fmla="val 3692"/>
             </a:avLst>
           </a:prstGeom>
           <a:solidFill>
-            <a:srgbClr val="EF4767">
-              <a:alpha val="25000"/>
-            </a:srgbClr>
+            <a:srgbClr val="FFFFFF"/>
           </a:solidFill>
-          <a:ln/>
-        </p:spPr>
-      </p:sp>
-      <p:sp>
-        <p:nvSpPr>
-          <p:cNvPr id="15" name="Text 12"/>
-          <p:cNvSpPr/>
-          <p:nvPr/>
-        </p:nvSpPr>
-        <p:spPr>
-          <a:xfrm>
-            <a:off x="7772400" y="4069080"/>
-            <a:ext cx="457200" cy="457200"/>
-          </a:xfrm>
-          <a:prstGeom prst="rect">
-            <a:avLst/>
-          </a:prstGeom>
-          <a:noFill/>
-          <a:ln/>
-        </p:spPr>
-        <p:txBody>
-          <a:bodyPr wrap="square" lIns="0" tIns="0" rIns="0" bIns="0" rtlCol="0" anchor="ctr"/>
-          <a:lstStyle/>
-          <a:p>
-            <a:pPr algn="ctr" indent="0" marL="0">
-              <a:buNone/>
-            </a:pPr>
-            <a:r>
-              <a:rPr lang="en-US" sz="1800" b="1" dirty="0">
-                <a:solidFill>
-                  <a:srgbClr val="EF4767"/>
-                </a:solidFill>
-                <a:latin typeface="Bookman Old Style" pitchFamily="34" charset="0"/>
-                <a:ea typeface="Bookman Old Style" pitchFamily="34" charset="-122"/>
-                <a:cs typeface="Bookman Old Style" pitchFamily="34" charset="-120"/>
-              </a:rPr>
-              <a:t>3</a:t>
-            </a:r>
-            <a:endParaRPr lang="en-US" sz="1800" dirty="0"/>
-          </a:p>
-        </p:txBody>
-      </p:sp>
-      <p:sp>
-        <p:nvSpPr>
-          <p:cNvPr id="16" name="Text 13"/>
-          <p:cNvSpPr/>
-          <p:nvPr/>
-        </p:nvSpPr>
-        <p:spPr>
-          <a:xfrm>
-            <a:off x="8412480" y="4023360"/>
-            <a:ext cx="3227832" cy="365760"/>
-          </a:xfrm>
-          <a:prstGeom prst="rect">
-            <a:avLst/>
-          </a:prstGeom>
-          <a:noFill/>
-          <a:ln/>
-        </p:spPr>
-        <p:txBody>
-          <a:bodyPr wrap="square" lIns="0" tIns="0" rIns="0" bIns="0" rtlCol="0" anchor="ctr"/>
-          <a:lstStyle/>
-          <a:p>
-            <a:pPr indent="0" marL="0">
-              <a:buNone/>
-            </a:pPr>
-            <a:r>
-              <a:rPr lang="en-US" sz="1600" b="1" dirty="0">
-                <a:solidFill>
-                  <a:srgbClr val="FFFFFF"/>
-                </a:solidFill>
-                <a:latin typeface="Bookman Old Style" pitchFamily="34" charset="0"/>
-                <a:ea typeface="Bookman Old Style" pitchFamily="34" charset="-122"/>
-                <a:cs typeface="Bookman Old Style" pitchFamily="34" charset="-120"/>
-              </a:rPr>
-              <a:t>See the why</a:t>
-            </a:r>
-            <a:endParaRPr lang="en-US" sz="1600" dirty="0"/>
-          </a:p>
-        </p:txBody>
-      </p:sp>
-      <p:sp>
-        <p:nvSpPr>
-          <p:cNvPr id="17" name="Text 14"/>
-          <p:cNvSpPr/>
-          <p:nvPr/>
-        </p:nvSpPr>
-        <p:spPr>
-          <a:xfrm>
-            <a:off x="8412480" y="4370832"/>
-            <a:ext cx="3227832" cy="640080"/>
-          </a:xfrm>
-          <a:prstGeom prst="rect">
-            <a:avLst/>
-          </a:prstGeom>
-          <a:noFill/>
-          <a:ln/>
-        </p:spPr>
-        <p:txBody>
-          <a:bodyPr wrap="square" lIns="0" tIns="0" rIns="0" bIns="0" rtlCol="0" anchor="ctr"/>
-          <a:lstStyle/>
-          <a:p>
-            <a:pPr indent="0" marL="0">
-              <a:buNone/>
-            </a:pPr>
-            <a:r>
-              <a:rPr lang="en-US" sz="1250" dirty="0">
-                <a:solidFill>
-                  <a:srgbClr val="9AA0BD"/>
-                </a:solidFill>
-                <a:latin typeface="Calibri" pitchFamily="34" charset="0"/>
-                <a:ea typeface="Calibri" pitchFamily="34" charset="-122"/>
-                <a:cs typeface="Calibri" pitchFamily="34" charset="-120"/>
-              </a:rPr>
-              <a:t>Top SHAP drivers behind the score.</a:t>
-            </a:r>
-            <a:endParaRPr lang="en-US" sz="1250" dirty="0"/>
-          </a:p>
-        </p:txBody>
-      </p:sp>
-      <p:sp>
-        <p:nvSpPr>
-          <p:cNvPr id="18" name="Shape 15"/>
-          <p:cNvSpPr/>
-          <p:nvPr/>
-        </p:nvSpPr>
-        <p:spPr>
-          <a:xfrm>
-            <a:off x="7772400" y="5212080"/>
-            <a:ext cx="3867912" cy="960120"/>
+          <a:ln w="12700">
+            <a:solidFill>
+              <a:srgbClr val="2E3450"/>
+            </a:solidFill>
+            <a:prstDash val="solid"/>
+          </a:ln>
+        </p:spPr>
+      </p:sp>
+      <p:pic>
+        <p:nvPicPr>
+          <p:cNvPr id="9" name="Image 1" descr="presentation/assets/demo_low_crop.png">    </p:cNvPr>
+          <p:cNvPicPr>
+            <a:picLocks noChangeAspect="1"/>
+          </p:cNvPicPr>
+          <p:nvPr/>
+        </p:nvPicPr>
+        <p:blipFill>
+          <a:blip r:embed="rId2"/>
+          <a:stretch>
+            <a:fillRect/>
+          </a:stretch>
+        </p:blipFill>
+        <p:spPr>
+          <a:xfrm>
+            <a:off x="6993331" y="2258568"/>
+            <a:ext cx="3853282" cy="2752344"/>
+          </a:xfrm>
+          <a:prstGeom prst="rect">
+            <a:avLst/>
+          </a:prstGeom>
+        </p:spPr>
+      </p:pic>
+      <p:sp>
+        <p:nvSpPr>
+          <p:cNvPr id="10" name="Shape 6"/>
+          <p:cNvSpPr/>
+          <p:nvPr/>
+        </p:nvSpPr>
+        <p:spPr>
+          <a:xfrm>
+            <a:off x="548640" y="5349240"/>
+            <a:ext cx="11091672" cy="960120"/>
           </a:xfrm>
           <a:prstGeom prst="roundRect">
             <a:avLst>
@@ -2870,14 +2604,14 @@
       </p:sp>
       <p:sp>
         <p:nvSpPr>
-          <p:cNvPr id="19" name="Text 16"/>
-          <p:cNvSpPr/>
-          <p:nvPr/>
-        </p:nvSpPr>
-        <p:spPr>
-          <a:xfrm>
-            <a:off x="8001000" y="5230368"/>
-            <a:ext cx="3410712" cy="914400"/>
+          <p:cNvPr id="11" name="Text 7"/>
+          <p:cNvSpPr/>
+          <p:nvPr/>
+        </p:nvSpPr>
+        <p:spPr>
+          <a:xfrm>
+            <a:off x="822960" y="5349240"/>
+            <a:ext cx="10515600" cy="960120"/>
           </a:xfrm>
           <a:prstGeom prst="rect">
             <a:avLst/>
@@ -2893,7 +2627,7 @@
               <a:buNone/>
             </a:pPr>
             <a:r>
-              <a:rPr lang="en-US" sz="1300" b="1" dirty="0">
+              <a:rPr lang="en-US" sz="1350" b="1" dirty="0">
                 <a:solidFill>
                   <a:srgbClr val="6C8CFF"/>
                 </a:solidFill>
@@ -2901,17 +2635,41 @@
                 <a:ea typeface="Calibri" pitchFamily="34" charset="-122"/>
                 <a:cs typeface="Calibri" pitchFamily="34" charset="-120"/>
               </a:rPr>
-              <a:t>Run it locally
-</a:t>
-            </a:r>
-            <a:endParaRPr lang="en-US" sz="1300" dirty="0"/>
-          </a:p>
-          <a:p>
+              <a:t>How it works:  </a:t>
+            </a:r>
             <a:pPr indent="0" marL="0">
               <a:buNone/>
             </a:pPr>
             <a:r>
-              <a:rPr lang="en-US" sz="1300" dirty="0">
+              <a:rPr lang="en-US" sz="1350" dirty="0">
+                <a:solidFill>
+                  <a:srgbClr val="D8DCEF"/>
+                </a:solidFill>
+                <a:latin typeface="Calibri" pitchFamily="34" charset="0"/>
+                <a:ea typeface="Calibri" pitchFamily="34" charset="-122"/>
+                <a:cs typeface="Calibri" pitchFamily="34" charset="-120"/>
+              </a:rPr>
+              <a:t>enter a customer → the model returns churn probability, a risk tier and a suggested action, with the top SHAP drivers explaining why.        </a:t>
+            </a:r>
+            <a:pPr indent="0" marL="0">
+              <a:buNone/>
+            </a:pPr>
+            <a:r>
+              <a:rPr lang="en-US" sz="1350" b="1" dirty="0">
+                <a:solidFill>
+                  <a:srgbClr val="F0A04B"/>
+                </a:solidFill>
+                <a:latin typeface="Calibri" pitchFamily="34" charset="0"/>
+                <a:ea typeface="Calibri" pitchFamily="34" charset="-122"/>
+                <a:cs typeface="Calibri" pitchFamily="34" charset="-120"/>
+              </a:rPr>
+              <a:t>Run:  </a:t>
+            </a:r>
+            <a:pPr indent="0" marL="0">
+              <a:buNone/>
+            </a:pPr>
+            <a:r>
+              <a:rPr lang="en-US" sz="1350" dirty="0">
                 <a:solidFill>
                   <a:srgbClr val="D8DCEF"/>
                 </a:solidFill>
@@ -2919,9 +2677,9 @@
                 <a:ea typeface="Consolas" pitchFamily="34" charset="-122"/>
                 <a:cs typeface="Consolas" pitchFamily="34" charset="-120"/>
               </a:rPr>
-              <a:t>python app.py  →  localhost:5000</a:t>
-            </a:r>
-            <a:endParaRPr lang="en-US" sz="1300" dirty="0"/>
+              <a:t>python app.py → localhost:5000</a:t>
+            </a:r>
+            <a:endParaRPr lang="en-US" sz="1350" dirty="0"/>
           </a:p>
         </p:txBody>
       </p:sp>

</xml_diff>

<commit_message>
Presentation: add key takeaways to the modeling & results slide
</commit_message>
<xml_diff>
--- a/presentation/Churn_Prediction_Final_Presentation.pptx
+++ b/presentation/Churn_Prediction_Final_Presentation.pptx
@@ -7461,11 +7461,11 @@
         <p:spPr>
           <a:xfrm>
             <a:off x="548640" y="1874520"/>
-            <a:ext cx="4754880" cy="512064"/>
+            <a:ext cx="4754880" cy="475488"/>
           </a:xfrm>
           <a:prstGeom prst="roundRect">
             <a:avLst>
-              <a:gd name="adj" fmla="val 10714"/>
+              <a:gd name="adj" fmla="val 11538"/>
             </a:avLst>
           </a:prstGeom>
           <a:solidFill>
@@ -7490,7 +7490,7 @@
         <p:spPr>
           <a:xfrm>
             <a:off x="685800" y="1874520"/>
-            <a:ext cx="2011680" cy="512064"/>
+            <a:ext cx="2011680" cy="475488"/>
           </a:xfrm>
           <a:prstGeom prst="rect">
             <a:avLst/>
@@ -7529,7 +7529,7 @@
         <p:spPr>
           <a:xfrm>
             <a:off x="2697480" y="1874520"/>
-            <a:ext cx="914400" cy="512064"/>
+            <a:ext cx="914400" cy="475488"/>
           </a:xfrm>
           <a:prstGeom prst="rect">
             <a:avLst/>
@@ -7568,7 +7568,7 @@
         <p:spPr>
           <a:xfrm>
             <a:off x="3611880" y="1874520"/>
-            <a:ext cx="822960" cy="512064"/>
+            <a:ext cx="822960" cy="475488"/>
           </a:xfrm>
           <a:prstGeom prst="rect">
             <a:avLst/>
@@ -7607,7 +7607,7 @@
         <p:spPr>
           <a:xfrm>
             <a:off x="4434840" y="1874520"/>
-            <a:ext cx="1005840" cy="512064"/>
+            <a:ext cx="1005840" cy="475488"/>
           </a:xfrm>
           <a:prstGeom prst="rect">
             <a:avLst/>
@@ -7645,12 +7645,12 @@
         </p:nvSpPr>
         <p:spPr>
           <a:xfrm>
-            <a:off x="548640" y="2441448"/>
-            <a:ext cx="4754880" cy="512064"/>
+            <a:off x="548640" y="2404872"/>
+            <a:ext cx="4754880" cy="475488"/>
           </a:xfrm>
           <a:prstGeom prst="roundRect">
             <a:avLst>
-              <a:gd name="adj" fmla="val 10714"/>
+              <a:gd name="adj" fmla="val 11538"/>
             </a:avLst>
           </a:prstGeom>
           <a:solidFill>
@@ -7672,8 +7672,8 @@
         </p:nvSpPr>
         <p:spPr>
           <a:xfrm>
-            <a:off x="685800" y="2441448"/>
-            <a:ext cx="2011680" cy="512064"/>
+            <a:off x="685800" y="2404872"/>
+            <a:ext cx="2011680" cy="475488"/>
           </a:xfrm>
           <a:prstGeom prst="rect">
             <a:avLst/>
@@ -7711,8 +7711,8 @@
         </p:nvSpPr>
         <p:spPr>
           <a:xfrm>
-            <a:off x="2697480" y="2441448"/>
-            <a:ext cx="914400" cy="512064"/>
+            <a:off x="2697480" y="2404872"/>
+            <a:ext cx="914400" cy="475488"/>
           </a:xfrm>
           <a:prstGeom prst="rect">
             <a:avLst/>
@@ -7750,8 +7750,8 @@
         </p:nvSpPr>
         <p:spPr>
           <a:xfrm>
-            <a:off x="3611880" y="2441448"/>
-            <a:ext cx="822960" cy="512064"/>
+            <a:off x="3611880" y="2404872"/>
+            <a:ext cx="822960" cy="475488"/>
           </a:xfrm>
           <a:prstGeom prst="rect">
             <a:avLst/>
@@ -7789,8 +7789,8 @@
         </p:nvSpPr>
         <p:spPr>
           <a:xfrm>
-            <a:off x="4434840" y="2441448"/>
-            <a:ext cx="1005840" cy="512064"/>
+            <a:off x="4434840" y="2404872"/>
+            <a:ext cx="1005840" cy="475488"/>
           </a:xfrm>
           <a:prstGeom prst="rect">
             <a:avLst/>
@@ -7828,12 +7828,12 @@
         </p:nvSpPr>
         <p:spPr>
           <a:xfrm>
-            <a:off x="548640" y="3008376"/>
-            <a:ext cx="4754880" cy="512064"/>
+            <a:off x="548640" y="2935224"/>
+            <a:ext cx="4754880" cy="475488"/>
           </a:xfrm>
           <a:prstGeom prst="roundRect">
             <a:avLst>
-              <a:gd name="adj" fmla="val 10714"/>
+              <a:gd name="adj" fmla="val 11538"/>
             </a:avLst>
           </a:prstGeom>
           <a:solidFill>
@@ -7855,8 +7855,8 @@
         </p:nvSpPr>
         <p:spPr>
           <a:xfrm>
-            <a:off x="685800" y="3008376"/>
-            <a:ext cx="2011680" cy="512064"/>
+            <a:off x="685800" y="2935224"/>
+            <a:ext cx="2011680" cy="475488"/>
           </a:xfrm>
           <a:prstGeom prst="rect">
             <a:avLst/>
@@ -7894,8 +7894,8 @@
         </p:nvSpPr>
         <p:spPr>
           <a:xfrm>
-            <a:off x="2697480" y="3008376"/>
-            <a:ext cx="914400" cy="512064"/>
+            <a:off x="2697480" y="2935224"/>
+            <a:ext cx="914400" cy="475488"/>
           </a:xfrm>
           <a:prstGeom prst="rect">
             <a:avLst/>
@@ -7933,8 +7933,8 @@
         </p:nvSpPr>
         <p:spPr>
           <a:xfrm>
-            <a:off x="3611880" y="3008376"/>
-            <a:ext cx="822960" cy="512064"/>
+            <a:off x="3611880" y="2935224"/>
+            <a:ext cx="822960" cy="475488"/>
           </a:xfrm>
           <a:prstGeom prst="rect">
             <a:avLst/>
@@ -7972,8 +7972,8 @@
         </p:nvSpPr>
         <p:spPr>
           <a:xfrm>
-            <a:off x="4434840" y="3008376"/>
-            <a:ext cx="1005840" cy="512064"/>
+            <a:off x="4434840" y="2935224"/>
+            <a:ext cx="1005840" cy="475488"/>
           </a:xfrm>
           <a:prstGeom prst="rect">
             <a:avLst/>
@@ -8011,12 +8011,12 @@
         </p:nvSpPr>
         <p:spPr>
           <a:xfrm>
-            <a:off x="548640" y="3575304"/>
-            <a:ext cx="4754880" cy="512064"/>
+            <a:off x="548640" y="3465576"/>
+            <a:ext cx="4754880" cy="475488"/>
           </a:xfrm>
           <a:prstGeom prst="roundRect">
             <a:avLst>
-              <a:gd name="adj" fmla="val 10714"/>
+              <a:gd name="adj" fmla="val 11538"/>
             </a:avLst>
           </a:prstGeom>
           <a:solidFill>
@@ -8038,8 +8038,8 @@
         </p:nvSpPr>
         <p:spPr>
           <a:xfrm>
-            <a:off x="685800" y="3575304"/>
-            <a:ext cx="2011680" cy="512064"/>
+            <a:off x="685800" y="3465576"/>
+            <a:ext cx="2011680" cy="475488"/>
           </a:xfrm>
           <a:prstGeom prst="rect">
             <a:avLst/>
@@ -8077,8 +8077,8 @@
         </p:nvSpPr>
         <p:spPr>
           <a:xfrm>
-            <a:off x="2697480" y="3575304"/>
-            <a:ext cx="914400" cy="512064"/>
+            <a:off x="2697480" y="3465576"/>
+            <a:ext cx="914400" cy="475488"/>
           </a:xfrm>
           <a:prstGeom prst="rect">
             <a:avLst/>
@@ -8116,8 +8116,8 @@
         </p:nvSpPr>
         <p:spPr>
           <a:xfrm>
-            <a:off x="3611880" y="3575304"/>
-            <a:ext cx="822960" cy="512064"/>
+            <a:off x="3611880" y="3465576"/>
+            <a:ext cx="822960" cy="475488"/>
           </a:xfrm>
           <a:prstGeom prst="rect">
             <a:avLst/>
@@ -8155,8 +8155,8 @@
         </p:nvSpPr>
         <p:spPr>
           <a:xfrm>
-            <a:off x="4434840" y="3575304"/>
-            <a:ext cx="1005840" cy="512064"/>
+            <a:off x="4434840" y="3465576"/>
+            <a:ext cx="1005840" cy="475488"/>
           </a:xfrm>
           <a:prstGeom prst="rect">
             <a:avLst/>
@@ -8188,60 +8188,285 @@
       </p:sp>
       <p:sp>
         <p:nvSpPr>
-          <p:cNvPr id="24" name="Text 22"/>
-          <p:cNvSpPr/>
-          <p:nvPr/>
-        </p:nvSpPr>
-        <p:spPr>
-          <a:xfrm>
-            <a:off x="548640" y="4279392"/>
-            <a:ext cx="4754880" cy="1097280"/>
-          </a:xfrm>
-          <a:prstGeom prst="rect">
-            <a:avLst/>
-          </a:prstGeom>
-          <a:noFill/>
-          <a:ln/>
-        </p:spPr>
-        <p:txBody>
-          <a:bodyPr wrap="square" lIns="0" tIns="0" rIns="0" bIns="0" rtlCol="0" anchor="ctr"/>
-          <a:lstStyle/>
-          <a:p>
-            <a:pPr indent="0" marL="0">
-              <a:buNone/>
-            </a:pPr>
-            <a:r>
-              <a:rPr lang="en-US" sz="1250" dirty="0">
-                <a:solidFill>
-                  <a:srgbClr val="D8DCEF"/>
+          <p:cNvPr id="24" name="Shape 22"/>
+          <p:cNvSpPr/>
+          <p:nvPr/>
+        </p:nvSpPr>
+        <p:spPr>
+          <a:xfrm>
+            <a:off x="548640" y="4224528"/>
+            <a:ext cx="137160" cy="137160"/>
+          </a:xfrm>
+          <a:prstGeom prst="roundRect">
+            <a:avLst>
+              <a:gd name="adj" fmla="val 46667"/>
+            </a:avLst>
+          </a:prstGeom>
+          <a:solidFill>
+            <a:srgbClr val="6C8CFF"/>
+          </a:solidFill>
+          <a:ln/>
+        </p:spPr>
+      </p:sp>
+      <p:sp>
+        <p:nvSpPr>
+          <p:cNvPr id="25" name="Text 23"/>
+          <p:cNvSpPr/>
+          <p:nvPr/>
+        </p:nvSpPr>
+        <p:spPr>
+          <a:xfrm>
+            <a:off x="822960" y="4087368"/>
+            <a:ext cx="4480560" cy="548640"/>
+          </a:xfrm>
+          <a:prstGeom prst="rect">
+            <a:avLst/>
+          </a:prstGeom>
+          <a:noFill/>
+          <a:ln/>
+        </p:spPr>
+        <p:txBody>
+          <a:bodyPr wrap="square" lIns="0" tIns="0" rIns="0" bIns="0" rtlCol="0" anchor="ctr"/>
+          <a:lstStyle/>
+          <a:p>
+            <a:pPr indent="0" marL="0">
+              <a:buNone/>
+            </a:pPr>
+            <a:r>
+              <a:rPr lang="en-US" sz="1300" b="1" dirty="0">
+                <a:solidFill>
+                  <a:srgbClr val="FFFFFF"/>
                 </a:solidFill>
                 <a:latin typeface="Calibri" pitchFamily="34" charset="0"/>
                 <a:ea typeface="Calibri" pitchFamily="34" charset="-122"/>
                 <a:cs typeface="Calibri" pitchFamily="34" charset="-120"/>
               </a:rPr>
-              <a:t>F2 is the primary metric (recall-weighted). </a:t>
-            </a:r>
-            <a:pPr indent="0" marL="0">
-              <a:buNone/>
-            </a:pPr>
-            <a:r>
-              <a:rPr lang="en-US" sz="1250" i="1" dirty="0">
-                <a:solidFill>
-                  <a:srgbClr val="9AA0BD"/>
+              <a:t>★ marks the pick — </a:t>
+            </a:r>
+            <a:pPr indent="0" marL="0">
+              <a:buNone/>
+            </a:pPr>
+            <a:r>
+              <a:rPr lang="en-US" sz="1300" dirty="0">
+                <a:solidFill>
+                  <a:srgbClr val="D8DCEF"/>
                 </a:solidFill>
                 <a:latin typeface="Calibri" pitchFamily="34" charset="0"/>
                 <a:ea typeface="Calibri" pitchFamily="34" charset="-122"/>
                 <a:cs typeface="Calibri" pitchFamily="34" charset="-120"/>
               </a:rPr>
+              <a:t>Random Forest wins on F2 (our primary metric).</a:t>
+            </a:r>
+            <a:endParaRPr lang="en-US" sz="1300" dirty="0"/>
+          </a:p>
+        </p:txBody>
+      </p:sp>
+      <p:sp>
+        <p:nvSpPr>
+          <p:cNvPr id="26" name="Shape 24"/>
+          <p:cNvSpPr/>
+          <p:nvPr/>
+        </p:nvSpPr>
+        <p:spPr>
+          <a:xfrm>
+            <a:off x="548640" y="4791456"/>
+            <a:ext cx="137160" cy="137160"/>
+          </a:xfrm>
+          <a:prstGeom prst="roundRect">
+            <a:avLst>
+              <a:gd name="adj" fmla="val 46667"/>
+            </a:avLst>
+          </a:prstGeom>
+          <a:solidFill>
+            <a:srgbClr val="6C8CFF"/>
+          </a:solidFill>
+          <a:ln/>
+        </p:spPr>
+      </p:sp>
+      <p:sp>
+        <p:nvSpPr>
+          <p:cNvPr id="27" name="Text 25"/>
+          <p:cNvSpPr/>
+          <p:nvPr/>
+        </p:nvSpPr>
+        <p:spPr>
+          <a:xfrm>
+            <a:off x="822960" y="4654296"/>
+            <a:ext cx="4480560" cy="548640"/>
+          </a:xfrm>
+          <a:prstGeom prst="rect">
+            <a:avLst/>
+          </a:prstGeom>
+          <a:noFill/>
+          <a:ln/>
+        </p:spPr>
+        <p:txBody>
+          <a:bodyPr wrap="square" lIns="0" tIns="0" rIns="0" bIns="0" rtlCol="0" anchor="ctr"/>
+          <a:lstStyle/>
+          <a:p>
+            <a:pPr indent="0" marL="0">
+              <a:buNone/>
+            </a:pPr>
+            <a:r>
+              <a:rPr lang="en-US" sz="1300" b="1" dirty="0">
+                <a:solidFill>
+                  <a:srgbClr val="FFFFFF"/>
+                </a:solidFill>
+                <a:latin typeface="Calibri" pitchFamily="34" charset="0"/>
+                <a:ea typeface="Calibri" pitchFamily="34" charset="-122"/>
+                <a:cs typeface="Calibri" pitchFamily="34" charset="-120"/>
+              </a:rPr>
+              <a:t>All three reach AUC ≈ 0.93 — </a:t>
+            </a:r>
+            <a:pPr indent="0" marL="0">
+              <a:buNone/>
+            </a:pPr>
+            <a:r>
+              <a:rPr lang="en-US" sz="1300" dirty="0">
+                <a:solidFill>
+                  <a:srgbClr val="D8DCEF"/>
+                </a:solidFill>
+                <a:latin typeface="Calibri" pitchFamily="34" charset="0"/>
+                <a:ea typeface="Calibri" pitchFamily="34" charset="-122"/>
+                <a:cs typeface="Calibri" pitchFamily="34" charset="-120"/>
+              </a:rPr>
+              <a:t>they separate churners from non-churners well.</a:t>
+            </a:r>
+            <a:endParaRPr lang="en-US" sz="1300" dirty="0"/>
+          </a:p>
+        </p:txBody>
+      </p:sp>
+      <p:sp>
+        <p:nvSpPr>
+          <p:cNvPr id="28" name="Shape 26"/>
+          <p:cNvSpPr/>
+          <p:nvPr/>
+        </p:nvSpPr>
+        <p:spPr>
+          <a:xfrm>
+            <a:off x="548640" y="5358384"/>
+            <a:ext cx="137160" cy="137160"/>
+          </a:xfrm>
+          <a:prstGeom prst="roundRect">
+            <a:avLst>
+              <a:gd name="adj" fmla="val 46667"/>
+            </a:avLst>
+          </a:prstGeom>
+          <a:solidFill>
+            <a:srgbClr val="6C8CFF"/>
+          </a:solidFill>
+          <a:ln/>
+        </p:spPr>
+      </p:sp>
+      <p:sp>
+        <p:nvSpPr>
+          <p:cNvPr id="29" name="Text 27"/>
+          <p:cNvSpPr/>
+          <p:nvPr/>
+        </p:nvSpPr>
+        <p:spPr>
+          <a:xfrm>
+            <a:off x="822960" y="5221224"/>
+            <a:ext cx="4480560" cy="548640"/>
+          </a:xfrm>
+          <a:prstGeom prst="rect">
+            <a:avLst/>
+          </a:prstGeom>
+          <a:noFill/>
+          <a:ln/>
+        </p:spPr>
+        <p:txBody>
+          <a:bodyPr wrap="square" lIns="0" tIns="0" rIns="0" bIns="0" rtlCol="0" anchor="ctr"/>
+          <a:lstStyle/>
+          <a:p>
+            <a:pPr indent="0" marL="0">
+              <a:buNone/>
+            </a:pPr>
+            <a:r>
+              <a:rPr lang="en-US" sz="1300" b="1" dirty="0">
+                <a:solidFill>
+                  <a:srgbClr val="FFFFFF"/>
+                </a:solidFill>
+                <a:latin typeface="Calibri" pitchFamily="34" charset="0"/>
+                <a:ea typeface="Calibri" pitchFamily="34" charset="-122"/>
+                <a:cs typeface="Calibri" pitchFamily="34" charset="-120"/>
+              </a:rPr>
+              <a:t>High recall (0.84) — </a:t>
+            </a:r>
+            <a:pPr indent="0" marL="0">
+              <a:buNone/>
+            </a:pPr>
+            <a:r>
+              <a:rPr lang="en-US" sz="1300" dirty="0">
+                <a:solidFill>
+                  <a:srgbClr val="D8DCEF"/>
+                </a:solidFill>
+                <a:latin typeface="Calibri" pitchFamily="34" charset="0"/>
+                <a:ea typeface="Calibri" pitchFamily="34" charset="-122"/>
+                <a:cs typeface="Calibri" pitchFamily="34" charset="-120"/>
+              </a:rPr>
+              <a:t>catches 84% of the customers who will leave.</a:t>
+            </a:r>
+            <a:endParaRPr lang="en-US" sz="1300" dirty="0"/>
+          </a:p>
+        </p:txBody>
+      </p:sp>
+      <p:sp>
+        <p:nvSpPr>
+          <p:cNvPr id="30" name="Text 28"/>
+          <p:cNvSpPr/>
+          <p:nvPr/>
+        </p:nvSpPr>
+        <p:spPr>
+          <a:xfrm>
+            <a:off x="548640" y="5925312"/>
+            <a:ext cx="4754880" cy="822960"/>
+          </a:xfrm>
+          <a:prstGeom prst="rect">
+            <a:avLst/>
+          </a:prstGeom>
+          <a:noFill/>
+          <a:ln/>
+        </p:spPr>
+        <p:txBody>
+          <a:bodyPr wrap="square" lIns="0" tIns="0" rIns="0" bIns="0" rtlCol="0" anchor="ctr"/>
+          <a:lstStyle/>
+          <a:p>
+            <a:pPr indent="0" marL="0">
+              <a:buNone/>
+            </a:pPr>
+            <a:r>
+              <a:rPr lang="en-US" sz="1200" dirty="0">
+                <a:solidFill>
+                  <a:srgbClr val="D8DCEF"/>
+                </a:solidFill>
+                <a:latin typeface="Calibri" pitchFamily="34" charset="0"/>
+                <a:ea typeface="Calibri" pitchFamily="34" charset="-122"/>
+                <a:cs typeface="Calibri" pitchFamily="34" charset="-120"/>
+              </a:rPr>
+              <a:t>F2 is recall-weighted. </a:t>
+            </a:r>
+            <a:pPr indent="0" marL="0">
+              <a:buNone/>
+            </a:pPr>
+            <a:r>
+              <a:rPr lang="en-US" sz="1200" i="1" dirty="0">
+                <a:solidFill>
+                  <a:srgbClr val="9AA0BD"/>
+                </a:solidFill>
+                <a:latin typeface="Calibri" pitchFamily="34" charset="0"/>
+                <a:ea typeface="Calibri" pitchFamily="34" charset="-122"/>
+                <a:cs typeface="Calibri" pitchFamily="34" charset="-120"/>
+              </a:rPr>
               <a:t>Low precision (~0.26) is expected at a 5% base rate with a recall-first threshold.</a:t>
             </a:r>
-            <a:endParaRPr lang="en-US" sz="1250" dirty="0"/>
-          </a:p>
-        </p:txBody>
-      </p:sp>
-      <p:sp>
-        <p:nvSpPr>
-          <p:cNvPr id="25" name="Shape 23"/>
+            <a:endParaRPr lang="en-US" sz="1200" dirty="0"/>
+          </a:p>
+        </p:txBody>
+      </p:sp>
+      <p:sp>
+        <p:nvSpPr>
+          <p:cNvPr id="31" name="Shape 29"/>
           <p:cNvSpPr/>
           <p:nvPr/>
         </p:nvSpPr>
@@ -8268,7 +8493,7 @@
       </p:sp>
       <p:pic>
         <p:nvPicPr>
-          <p:cNvPr id="26" name="Image 0" descr="outputs/figures/pr_curves.png">    </p:cNvPr>
+          <p:cNvPr id="32" name="Image 0" descr="outputs/figures/pr_curves.png">    </p:cNvPr>
           <p:cNvPicPr>
             <a:picLocks noChangeAspect="1"/>
           </p:cNvPicPr>
@@ -8292,7 +8517,7 @@
       </p:pic>
       <p:sp>
         <p:nvSpPr>
-          <p:cNvPr id="27" name="Shape 24"/>
+          <p:cNvPr id="33" name="Shape 30"/>
           <p:cNvSpPr/>
           <p:nvPr/>
         </p:nvSpPr>
@@ -8319,7 +8544,7 @@
       </p:sp>
       <p:pic>
         <p:nvPicPr>
-          <p:cNvPr id="28" name="Image 1" descr="outputs/figures/confusion_matrix.png">    </p:cNvPr>
+          <p:cNvPr id="34" name="Image 1" descr="outputs/figures/confusion_matrix.png">    </p:cNvPr>
           <p:cNvPicPr>
             <a:picLocks noChangeAspect="1"/>
           </p:cNvPicPr>

</xml_diff>

<commit_message>
Presentation: add 'Why F2?' explanation callout to the ML formulation slide
</commit_message>
<xml_diff>
--- a/presentation/Churn_Prediction_Final_Presentation.pptx
+++ b/presentation/Churn_Prediction_Final_Presentation.pptx
@@ -952,7 +952,7 @@
           <a:p>
             <a:r>
               <a:rPr lang="en-US" dirty="0"/>
-              <a:t>Formally: supervised binary classification. Target is whether a customer cancels within 30 days. We optimise F2 because recall matters more than precision here, and we validate on a time-based split to mimic production and avoid leakage.</a:t>
+              <a:t>Formally: supervised binary classification. Target is whether a customer cancels within 30 days. We optimise F2 because recall matters more than precision here — missing a churner costs far more than a false alert — and we validate on a time-based split to mimic production and avoid leakage.</a:t>
             </a:r>
             <a:endParaRPr lang="en-US" dirty="0"/>
           </a:p>
@@ -5031,11 +5031,11 @@
         <p:spPr>
           <a:xfrm>
             <a:off x="548640" y="1874520"/>
-            <a:ext cx="11091672" cy="713232"/>
+            <a:ext cx="11091672" cy="566928"/>
           </a:xfrm>
           <a:prstGeom prst="roundRect">
             <a:avLst>
-              <a:gd name="adj" fmla="val 15385"/>
+              <a:gd name="adj" fmla="val 19355"/>
             </a:avLst>
           </a:prstGeom>
           <a:solidFill>
@@ -5058,7 +5058,7 @@
         <p:spPr>
           <a:xfrm>
             <a:off x="822960" y="1874520"/>
-            <a:ext cx="2651760" cy="713232"/>
+            <a:ext cx="2651760" cy="566928"/>
           </a:xfrm>
           <a:prstGeom prst="rect">
             <a:avLst/>
@@ -5097,7 +5097,7 @@
         <p:spPr>
           <a:xfrm>
             <a:off x="3566160" y="1874520"/>
-            <a:ext cx="7799832" cy="713232"/>
+            <a:ext cx="7799832" cy="566928"/>
           </a:xfrm>
           <a:prstGeom prst="rect">
             <a:avLst/>
@@ -5135,12 +5135,12 @@
         </p:nvSpPr>
         <p:spPr>
           <a:xfrm>
-            <a:off x="548640" y="2615184"/>
-            <a:ext cx="11091672" cy="713232"/>
+            <a:off x="548640" y="2468880"/>
+            <a:ext cx="11091672" cy="566928"/>
           </a:xfrm>
           <a:prstGeom prst="roundRect">
             <a:avLst>
-              <a:gd name="adj" fmla="val 15385"/>
+              <a:gd name="adj" fmla="val 19355"/>
             </a:avLst>
           </a:prstGeom>
           <a:solidFill>
@@ -5162,8 +5162,8 @@
         </p:nvSpPr>
         <p:spPr>
           <a:xfrm>
-            <a:off x="822960" y="2615184"/>
-            <a:ext cx="2651760" cy="713232"/>
+            <a:off x="822960" y="2468880"/>
+            <a:ext cx="2651760" cy="566928"/>
           </a:xfrm>
           <a:prstGeom prst="rect">
             <a:avLst/>
@@ -5201,8 +5201,8 @@
         </p:nvSpPr>
         <p:spPr>
           <a:xfrm>
-            <a:off x="3566160" y="2615184"/>
-            <a:ext cx="7799832" cy="713232"/>
+            <a:off x="3566160" y="2468880"/>
+            <a:ext cx="7799832" cy="566928"/>
           </a:xfrm>
           <a:prstGeom prst="rect">
             <a:avLst/>
@@ -5240,12 +5240,12 @@
         </p:nvSpPr>
         <p:spPr>
           <a:xfrm>
-            <a:off x="548640" y="3355848"/>
-            <a:ext cx="11091672" cy="713232"/>
+            <a:off x="548640" y="3063240"/>
+            <a:ext cx="11091672" cy="566928"/>
           </a:xfrm>
           <a:prstGeom prst="roundRect">
             <a:avLst>
-              <a:gd name="adj" fmla="val 15385"/>
+              <a:gd name="adj" fmla="val 19355"/>
             </a:avLst>
           </a:prstGeom>
           <a:solidFill>
@@ -5267,8 +5267,8 @@
         </p:nvSpPr>
         <p:spPr>
           <a:xfrm>
-            <a:off x="822960" y="3355848"/>
-            <a:ext cx="2651760" cy="713232"/>
+            <a:off x="822960" y="3063240"/>
+            <a:ext cx="2651760" cy="566928"/>
           </a:xfrm>
           <a:prstGeom prst="rect">
             <a:avLst/>
@@ -5306,8 +5306,8 @@
         </p:nvSpPr>
         <p:spPr>
           <a:xfrm>
-            <a:off x="3566160" y="3355848"/>
-            <a:ext cx="7799832" cy="713232"/>
+            <a:off x="3566160" y="3063240"/>
+            <a:ext cx="7799832" cy="566928"/>
           </a:xfrm>
           <a:prstGeom prst="rect">
             <a:avLst/>
@@ -5345,12 +5345,12 @@
         </p:nvSpPr>
         <p:spPr>
           <a:xfrm>
-            <a:off x="548640" y="4096512"/>
-            <a:ext cx="11091672" cy="713232"/>
+            <a:off x="548640" y="3657600"/>
+            <a:ext cx="11091672" cy="566928"/>
           </a:xfrm>
           <a:prstGeom prst="roundRect">
             <a:avLst>
-              <a:gd name="adj" fmla="val 15385"/>
+              <a:gd name="adj" fmla="val 19355"/>
             </a:avLst>
           </a:prstGeom>
           <a:solidFill>
@@ -5372,8 +5372,8 @@
         </p:nvSpPr>
         <p:spPr>
           <a:xfrm>
-            <a:off x="822960" y="4096512"/>
-            <a:ext cx="2651760" cy="713232"/>
+            <a:off x="822960" y="3657600"/>
+            <a:ext cx="2651760" cy="566928"/>
           </a:xfrm>
           <a:prstGeom prst="rect">
             <a:avLst/>
@@ -5411,8 +5411,8 @@
         </p:nvSpPr>
         <p:spPr>
           <a:xfrm>
-            <a:off x="3566160" y="4096512"/>
-            <a:ext cx="7799832" cy="713232"/>
+            <a:off x="3566160" y="3657600"/>
+            <a:ext cx="7799832" cy="566928"/>
           </a:xfrm>
           <a:prstGeom prst="rect">
             <a:avLst/>
@@ -5450,12 +5450,12 @@
         </p:nvSpPr>
         <p:spPr>
           <a:xfrm>
-            <a:off x="548640" y="4837176"/>
-            <a:ext cx="11091672" cy="713232"/>
+            <a:off x="548640" y="4251960"/>
+            <a:ext cx="11091672" cy="566928"/>
           </a:xfrm>
           <a:prstGeom prst="roundRect">
             <a:avLst>
-              <a:gd name="adj" fmla="val 15385"/>
+              <a:gd name="adj" fmla="val 19355"/>
             </a:avLst>
           </a:prstGeom>
           <a:solidFill>
@@ -5477,8 +5477,8 @@
         </p:nvSpPr>
         <p:spPr>
           <a:xfrm>
-            <a:off x="822960" y="4837176"/>
-            <a:ext cx="2651760" cy="713232"/>
+            <a:off x="822960" y="4251960"/>
+            <a:ext cx="2651760" cy="566928"/>
           </a:xfrm>
           <a:prstGeom prst="rect">
             <a:avLst/>
@@ -5516,8 +5516,8 @@
         </p:nvSpPr>
         <p:spPr>
           <a:xfrm>
-            <a:off x="3566160" y="4837176"/>
-            <a:ext cx="7799832" cy="713232"/>
+            <a:off x="3566160" y="4251960"/>
+            <a:ext cx="7799832" cy="566928"/>
           </a:xfrm>
           <a:prstGeom prst="rect">
             <a:avLst/>
@@ -5555,12 +5555,12 @@
         </p:nvSpPr>
         <p:spPr>
           <a:xfrm>
-            <a:off x="548640" y="5577840"/>
-            <a:ext cx="11091672" cy="713232"/>
+            <a:off x="548640" y="4846320"/>
+            <a:ext cx="11091672" cy="566928"/>
           </a:xfrm>
           <a:prstGeom prst="roundRect">
             <a:avLst>
-              <a:gd name="adj" fmla="val 15385"/>
+              <a:gd name="adj" fmla="val 19355"/>
             </a:avLst>
           </a:prstGeom>
           <a:solidFill>
@@ -5582,8 +5582,8 @@
         </p:nvSpPr>
         <p:spPr>
           <a:xfrm>
-            <a:off x="822960" y="5577840"/>
-            <a:ext cx="2651760" cy="713232"/>
+            <a:off x="822960" y="4846320"/>
+            <a:ext cx="2651760" cy="566928"/>
           </a:xfrm>
           <a:prstGeom prst="rect">
             <a:avLst/>
@@ -5621,8 +5621,8 @@
         </p:nvSpPr>
         <p:spPr>
           <a:xfrm>
-            <a:off x="3566160" y="5577840"/>
-            <a:ext cx="7799832" cy="713232"/>
+            <a:off x="3566160" y="4846320"/>
+            <a:ext cx="7799832" cy="566928"/>
           </a:xfrm>
           <a:prstGeom prst="rect">
             <a:avLst/>
@@ -5649,6 +5649,114 @@
               <a:t>Time-based split — train on the past, test on the future (no data leakage)</a:t>
             </a:r>
             <a:endParaRPr lang="en-US" sz="1500" dirty="0"/>
+          </a:p>
+        </p:txBody>
+      </p:sp>
+      <p:sp>
+        <p:nvSpPr>
+          <p:cNvPr id="22" name="Shape 20"/>
+          <p:cNvSpPr/>
+          <p:nvPr/>
+        </p:nvSpPr>
+        <p:spPr>
+          <a:xfrm>
+            <a:off x="548640" y="5577840"/>
+            <a:ext cx="11091672" cy="868680"/>
+          </a:xfrm>
+          <a:prstGeom prst="roundRect">
+            <a:avLst>
+              <a:gd name="adj" fmla="val 12632"/>
+            </a:avLst>
+          </a:prstGeom>
+          <a:solidFill>
+            <a:srgbClr val="232840"/>
+          </a:solidFill>
+          <a:ln w="12700">
+            <a:solidFill>
+              <a:srgbClr val="2E3450"/>
+            </a:solidFill>
+            <a:prstDash val="solid"/>
+          </a:ln>
+        </p:spPr>
+      </p:sp>
+      <p:sp>
+        <p:nvSpPr>
+          <p:cNvPr id="23" name="Text 21"/>
+          <p:cNvSpPr/>
+          <p:nvPr/>
+        </p:nvSpPr>
+        <p:spPr>
+          <a:xfrm>
+            <a:off x="868680" y="5577840"/>
+            <a:ext cx="10451592" cy="868680"/>
+          </a:xfrm>
+          <a:prstGeom prst="rect">
+            <a:avLst/>
+          </a:prstGeom>
+          <a:noFill/>
+          <a:ln/>
+        </p:spPr>
+        <p:txBody>
+          <a:bodyPr wrap="square" lIns="0" tIns="0" rIns="0" bIns="0" rtlCol="0" anchor="ctr"/>
+          <a:lstStyle/>
+          <a:p>
+            <a:pPr indent="0" marL="0">
+              <a:buNone/>
+            </a:pPr>
+            <a:r>
+              <a:rPr lang="en-US" sz="1400" b="1" dirty="0">
+                <a:solidFill>
+                  <a:srgbClr val="F0A04B"/>
+                </a:solidFill>
+                <a:latin typeface="Calibri" pitchFamily="34" charset="0"/>
+                <a:ea typeface="Calibri" pitchFamily="34" charset="-122"/>
+                <a:cs typeface="Calibri" pitchFamily="34" charset="-120"/>
+              </a:rPr>
+              <a:t>Why F2?  </a:t>
+            </a:r>
+            <a:pPr indent="0" marL="0">
+              <a:buNone/>
+            </a:pPr>
+            <a:r>
+              <a:rPr lang="en-US" sz="1400" dirty="0">
+                <a:solidFill>
+                  <a:srgbClr val="D8DCEF"/>
+                </a:solidFill>
+                <a:latin typeface="Calibri" pitchFamily="34" charset="0"/>
+                <a:ea typeface="Calibri" pitchFamily="34" charset="-122"/>
+                <a:cs typeface="Calibri" pitchFamily="34" charset="-120"/>
+              </a:rPr>
+              <a:t>F2 blends recall and precision but weights </a:t>
+            </a:r>
+            <a:pPr indent="0" marL="0">
+              <a:buNone/>
+            </a:pPr>
+            <a:r>
+              <a:rPr lang="en-US" sz="1400" b="1" dirty="0">
+                <a:solidFill>
+                  <a:srgbClr val="FFFFFF"/>
+                </a:solidFill>
+                <a:latin typeface="Calibri" pitchFamily="34" charset="0"/>
+                <a:ea typeface="Calibri" pitchFamily="34" charset="-122"/>
+                <a:cs typeface="Calibri" pitchFamily="34" charset="-120"/>
+              </a:rPr>
+              <a:t>recall ~4× higher</a:t>
+            </a:r>
+            <a:pPr indent="0" marL="0">
+              <a:buNone/>
+            </a:pPr>
+            <a:r>
+              <a:rPr lang="en-US" sz="1400" dirty="0">
+                <a:solidFill>
+                  <a:srgbClr val="D8DCEF"/>
+                </a:solidFill>
+                <a:latin typeface="Calibri" pitchFamily="34" charset="0"/>
+                <a:ea typeface="Calibri" pitchFamily="34" charset="-122"/>
+                <a:cs typeface="Calibri" pitchFamily="34" charset="-120"/>
+              </a:rPr>
+              <a:t> — because missing a churner (≈12 months of lost revenue) costs far more than sending a loyal customer an unneeded offer.</a:t>
+            </a:r>
+            <a:endParaRPr lang="en-US" sz="1400" dirty="0"/>
           </a:p>
         </p:txBody>
       </p:sp>

</xml_diff>